<commit_message>
Proofread courseware concepts, quizzes, and slide numbering
</commit_message>
<xml_diff>
--- a/courseware/202609_DSA_MOOC_Quiz_CH03-04.pptx
+++ b/courseware/202609_DSA_MOOC_Quiz_CH03-04.pptx
@@ -25050,7 +25050,7 @@
                 <a:ea typeface="Microsoft YaHei" pitchFamily="34" charset="-122"/>
                 <a:cs typeface="Microsoft YaHei" pitchFamily="34" charset="-120"/>
               </a:rPr>
-              <a:t>双端队列可以在队列的两端进行插入和删除操作。现有 4 个不同的元素顺序输入到双端队列，那么可以得到 ____ 种不同的排列。</a:t>
+              <a:t>双端队列可以在队列的两端进行插入和删除操作。现有 4 个不同的元素依次从任一端全部入队，再从固定一端依次出队，可以得到 ____ 种不同的排列。</a:t>
             </a:r>
             <a:endParaRPr lang="en-US" sz="2000" dirty="0"/>
           </a:p>
@@ -25253,7 +25253,7 @@
                 <a:ea typeface="Microsoft YaHei" pitchFamily="34" charset="-122"/>
                 <a:cs typeface="Microsoft YaHei" pitchFamily="34" charset="-120"/>
               </a:rPr>
-              <a:t>按题库答案理解：4 个元素先全部入队（每个从左端或右端进入），再从一端依次出队。</a:t>
+              <a:t>本题限定：先全部入队，再从固定一端依次出队；入队、出队不交错。</a:t>
             </a:r>
             <a:endParaRPr lang="en-US" sz="1700" dirty="0"/>
           </a:p>

</xml_diff>